<commit_message>
mesh: 24- and 29-qubit results with the tuned QAOA settings (HPC), report and slide 9 updated
Settings frozen from n = 20 (p = 3, 5, 8), no training at 24 / 29 qubits; noiseless; 6 test meshes per
scenario (cases 2 and 9, seeds 7-9). Near-best split found within 1,000 tries:
- 29 qubits, p = 8: equal devices 88 % (spectral 50 %, annealing 10 %, local search 5 %);
  CPU + GPU 99.6 % (spectral 100 %, annealing 43 %, local search 46 %). First 29-qubit run: 0.7 %.
- 24 qubits, p = 8: 99 % / 100 % (spectral 50 % / 83 %).
Deep circuits (3,248 two-qubit gates at 29 qubits); no quantum-advantage claim.
Also: the server's 14 part files of the 12-qubit study (hpc_parts/), the logs, the tuned settings
file, and a report fix (the first 29-qubit run no longer overwrites the tuned one).

Co-Authored-By: Claude Opus 5.5 <noreply@anthropic.com>
</commit_message>
<xml_diff>
--- a/mesh/slides/mesh_ZollerQu.pptx
+++ b/mesh/slides/mesh_ZollerQu.pptx
@@ -10780,27 +10780,27 @@
         </p:nvSpPr>
         <p:spPr>
           <a:xfrm>
-            <a:off x="4983480" y="5230368"/>
-            <a:ext cx="6858000" cy="502920"/>
-          </a:xfrm>
-          <a:prstGeom prst="rect">
-            <a:avLst/>
-          </a:prstGeom>
-          <a:noFill/>
-        </p:spPr>
-        <p:txBody>
-          <a:bodyPr wrap="none" lIns="0" rIns="0" tIns="0" bIns="0" anchor="t">
-            <a:spAutoFit/>
-          </a:bodyPr>
-          <a:lstStyle/>
-          <a:p>
-            <a:pPr algn="l">
-              <a:lnSpc>
-                <a:spcPts val="1800"/>
-              </a:lnSpc>
-            </a:pPr>
-            <a:r>
-              <a:rPr sz="1500" b="0" i="0">
+            <a:off x="4983480" y="5074920"/>
+            <a:ext cx="6858000" cy="685800"/>
+          </a:xfrm>
+          <a:prstGeom prst="rect">
+            <a:avLst/>
+          </a:prstGeom>
+          <a:noFill/>
+        </p:spPr>
+        <p:txBody>
+          <a:bodyPr wrap="none" lIns="0" rIns="0" tIns="0" bIns="0" anchor="t">
+            <a:spAutoFit/>
+          </a:bodyPr>
+          <a:lstStyle/>
+          <a:p>
+            <a:pPr algn="l">
+              <a:lnSpc>
+                <a:spcPts val="1680"/>
+              </a:lnSpc>
+            </a:pPr>
+            <a:r>
+              <a:rPr sz="1400" b="0" i="0">
                 <a:solidFill>
                   <a:srgbClr val="FAFAFA"/>
                 </a:solidFill>
@@ -10812,17 +10812,33 @@
           <a:p>
             <a:pPr algn="l">
               <a:lnSpc>
-                <a:spcPts val="1800"/>
-              </a:lnSpc>
-            </a:pPr>
-            <a:r>
-              <a:rPr sz="1500" b="0" i="0">
+                <a:spcPts val="1680"/>
+              </a:lnSpc>
+            </a:pPr>
+            <a:r>
+              <a:rPr sz="1400" b="0" i="0">
                 <a:solidFill>
                   <a:srgbClr val="FAFAFA"/>
                 </a:solidFill>
                 <a:latin typeface="Arial"/>
               </a:rPr>
               <a:t>20 qubits, 6 layers: 0.62 % / 1.69 % (before 0.014 % / 0.035 %)</a:t>
+            </a:r>
+          </a:p>
+          <a:p>
+            <a:pPr algn="l">
+              <a:lnSpc>
+                <a:spcPts val="1680"/>
+              </a:lnSpc>
+            </a:pPr>
+            <a:r>
+              <a:rPr sz="1400" b="0" i="0">
+                <a:solidFill>
+                  <a:srgbClr val="FAFAFA"/>
+                </a:solidFill>
+                <a:latin typeface="Arial"/>
+              </a:rPr>
+              <a:t>29 qubits, 8 layers, found in 1,000 tries: 88 % / 100 % (spectral 50 % / 100 %)</a:t>
             </a:r>
           </a:p>
         </p:txBody>

</xml_diff>